<commit_message>
feat(me2): organize repository, archive obsolete runs, and track benchmark reproducibility artifacts
</commit_message>
<xml_diff>
--- a/Dumalaog_ME2 - Tiny Voice Command Model/docs/slides/ME2_VCM_Gold_Live_Benchmark_20261003.pptx
+++ b/Dumalaog_ME2 - Tiny Voice Command Model/docs/slides/ME2_VCM_Gold_Live_Benchmark_20261003.pptx
@@ -2869,7 +2869,7 @@
                 <a:ea typeface="Arial"/>
                 <a:cs typeface="Arial"/>
               </a:rPr>
-              <a:t>Live Gold holdout · 202 clips · Raspberry Pi audio test</a:t>
+              <a:t>Raspberry Pi 5 Holdout Benchmark · 125 Evaluated Trials · On-Device INT8</a:t>
             </a:r>
           </a:p>
         </p:txBody>
@@ -2927,7 +2927,7 @@
                 <a:ea typeface="Arial"/>
                 <a:cs typeface="Arial"/>
               </a:rPr>
-              <a:t>~61 min</a:t>
+              <a:t>71.6%</a:t>
             </a:r>
           </a:p>
         </p:txBody>
@@ -2985,7 +2985,7 @@
                 <a:ea typeface="Arial"/>
                 <a:cs typeface="Arial"/>
               </a:rPr>
-              <a:t>full run · timed trials only</a:t>
+              <a:t>intent accuracy · 72.7% macro F1</a:t>
             </a:r>
           </a:p>
         </p:txBody>
@@ -3043,7 +3043,7 @@
                 <a:ea typeface="Arial"/>
                 <a:cs typeface="Arial"/>
               </a:rPr>
-              <a:t>~34 min</a:t>
+              <a:t>97.7%</a:t>
             </a:r>
           </a:p>
         </p:txBody>
@@ -3101,7 +3101,7 @@
                 <a:ea typeface="Arial"/>
                 <a:cs typeface="Arial"/>
               </a:rPr>
-              <a:t>quick run · timed trials only</a:t>
+              <a:t>slot exact match · 100% timer/temp</a:t>
             </a:r>
           </a:p>
         </p:txBody>
@@ -3159,7 +3159,7 @@
                 <a:ea typeface="Arial"/>
                 <a:cs typeface="Arial"/>
               </a:rPr>
-              <a:t>218</a:t>
+              <a:t>6.3 ms</a:t>
             </a:r>
           </a:p>
         </p:txBody>
@@ -3217,7 +3217,7 @@
                 <a:ea typeface="Arial"/>
                 <a:cs typeface="Arial"/>
               </a:rPr>
-              <a:t>full trials · includes 16 no-wake</a:t>
+              <a:t>Pi 5 latency · 0.003 real-time factor</a:t>
             </a:r>
           </a:p>
         </p:txBody>
@@ -3305,7 +3305,7 @@
                 <a:ea typeface="Arial"/>
                 <a:cs typeface="Arial"/>
               </a:rPr>
-              <a:t>Live test runtime</a:t>
+              <a:t>Benchmark Classification Accuracy</a:t>
             </a:r>
           </a:p>
         </p:txBody>
@@ -3363,7 +3363,7 @@
                 <a:ea typeface="Arial"/>
                 <a:cs typeface="Arial"/>
               </a:rPr>
-              <a:t>Full: 202 holdout clips + 16 no-wake controls</a:t>
+              <a:t>19-class intent accuracy: 71.6% [95% CI: 62.5%–79.2%]</a:t>
             </a:r>
           </a:p>
         </p:txBody>
@@ -3421,7 +3421,7 @@
                 <a:ea typeface="Arial"/>
                 <a:cs typeface="Arial"/>
               </a:rPr>
-              <a:t>Quick: 93 variations + 16 OOS + 16 controls</a:t>
+              <a:t>93-variation command accuracy: 70.6% (macro F1: 72.7%)</a:t>
             </a:r>
           </a:p>
         </p:txBody>
@@ -3479,7 +3479,7 @@
                 <a:ea typeface="Arial"/>
                 <a:cs typeface="Arial"/>
               </a:rPr>
-              <a:t>Random 10–15 s gaps; trial time excludes setup</a:t>
+              <a:t>Voice breakdown: 90.0% synthetic voice · 49.0% real voice</a:t>
             </a:r>
           </a:p>
         </p:txBody>
@@ -3537,7 +3537,7 @@
                 <a:ea typeface="Arial"/>
                 <a:cs typeface="Arial"/>
               </a:rPr>
-              <a:t>Mic check, log validation and two warm-ups add time</a:t>
+              <a:t>Wake gating: 100.0% detect rate · 0.0% false wake (0/16)</a:t>
             </a:r>
           </a:p>
         </p:txBody>
@@ -3625,7 +3625,7 @@
                 <a:ea typeface="Arial"/>
                 <a:cs typeface="Arial"/>
               </a:rPr>
-              <a:t>Scope and readiness</a:t>
+              <a:t>Raspberry Pi 5 Hardware &amp; Runtime</a:t>
             </a:r>
           </a:p>
         </p:txBody>
@@ -3683,7 +3683,7 @@
                 <a:ea typeface="Arial"/>
                 <a:cs typeface="Arial"/>
               </a:rPr>
-              <a:t>Live Pi holdout test, not the static 4,443-row Gold replay.</a:t>
+              <a:t>Evaluated on deployed INT8 models (39.3 KB intent + 37.4 KB wake).</a:t>
             </a:r>
           </a:p>
         </p:txBody>
@@ -3741,7 +3741,7 @@
                 <a:ea typeface="Arial"/>
                 <a:cs typeface="Arial"/>
               </a:rPr>
-              <a:t>Pi log needs intent, infer_ms and audio_ms for every decision.</a:t>
+              <a:t>Inference: 6.3 ms mean (7.2 ms p95) · RTF 0.003 · Peak RAM 143 MB</a:t>
             </a:r>
           </a:p>
         </p:txBody>
@@ -3799,7 +3799,7 @@
                 <a:ea typeface="Arial"/>
                 <a:cs typeface="Arial"/>
               </a:rPr>
-              <a:t>ME2 app is stopped; start it first. Gold candidate remains removed.</a:t>
+              <a:t>Slots: 100% timer, temp, brightness, color; 85.7% alarm. Max temp 49°C.</a:t>
             </a:r>
           </a:p>
         </p:txBody>

</xml_diff>